<commit_message>
Sync deck diagram to 7 agents (add Returns & Refunds); regenerate exports
- assets/architecture.svg/png: add Returns & Refunds as a 7th agent
  ('NEW — just a contract'), dropped the now-redundant 'Product #N' box
  (it overlapped the 'Why it scales' callout)
- DECK.md prose updated 6 -> 7 agents to match the diagram
- Regenerated deck PDF + PPTX (full + short) with the new diagram

Co-Authored-By: Claude Opus 4.8 <noreply@anthropic.com>
Claude-Session: https://claude.ai/code/session_01YSBd5UwWXaz3oS3KJNG9Fg
</commit_message>
<xml_diff>
--- a/exports/Velocity-Context-Layer-Deck-SHORT.pptx
+++ b/exports/Velocity-Context-Layer-Deck-SHORT.pptx
@@ -512,7 +512,7 @@
           <a:lstStyle/>
           <a:p>
             <a:r>
-              <a:t>Open here, in one breath. I didn't build one agent — I built the layer that makes all of them possible. A CDP tells you WHO the customer is; this tells the agent WHAT it needs to act, right now. Don't read the slide — say this line and move.</a:t>
+              <a:t>Open here, one breath. I didn't build one agent — I built the layer that makes all of them possible. A CDP tells you WHO; this tells the agent WHAT it needs, right now.</a:t>
             </a:r>
           </a:p>
         </p:txBody>
@@ -582,7 +582,7 @@
           <a:lstStyle/>
           <a:p>
             <a:r>
-              <a:t>Criterion five. Foundation first — nothing works without identity and the stores. Then low-regret, clean-data agents: WIMO, cart, COD-to-prepaid. I order by value times data-readiness times reversibility of risk.</a:t>
+              <a:t>Criterion five. Foundation first — nothing works without identity and the stores. Then low-regret agents: WIMO, cart, COD-to-prepaid. Value times data-readiness times reversibility of risk.</a:t>
             </a:r>
           </a:p>
         </p:txBody>
@@ -652,7 +652,7 @@
           <a:lstStyle/>
           <a:p>
             <a:r>
-              <a:t>Close on this, then stop. Today's agent gets smarter the day this ships; every future agent just declares a contract; across many brands the data compounds into a moat. Then the four reasons it's the RIGHT answer, not just an answer. End there.</a:t>
+              <a:t>Close on this, then stop. Today's agent gets smarter now; every future agent is just a contract; across brands the data compounds into a moat. Then the four reasons it's the right answer.</a:t>
             </a:r>
           </a:p>
         </p:txBody>
@@ -722,7 +722,7 @@
           <a:lstStyle/>
           <a:p>
             <a:r>
-              <a:t>Open here, in one breath. I didn't build one agent — I built the layer that makes all of them possible. A CDP tells you WHO the customer is; this tells the agent WHAT it needs to act, right now. Don't read the slide — say this line and move.</a:t>
+              <a:t>Open here, one breath. I didn't build one agent — I built the layer that makes all of them possible. A CDP tells you WHO; this tells the agent WHAT it needs, right now.</a:t>
             </a:r>
           </a:p>
         </p:txBody>
@@ -792,7 +792,7 @@
           <a:lstStyle/>
           <a:p>
             <a:r>
-              <a:t>Velocity's data is scattered and the same person is several records. Ten products on the roadmap, and every single one fails the same way — it acts on partial context. So the bottleneck isn't the agents; it's the context underneath them. Pause on that.</a:t>
+              <a:t>Data is scattered and the same person is several records. Ten products on the roadmap, every one fails the same way — partial context. The bottleneck isn't the agents; it's the context underneath.</a:t>
             </a:r>
           </a:p>
         </p:txBody>
@@ -862,7 +862,7 @@
           <a:lstStyle/>
           <a:p>
             <a:r>
-              <a:t>This is THE key slide. CDP is profile-first — one big record. We're job-first — a tight bundle per task. And I didn't design the schema in a vacuum: I let the agents' NEEDS be the forcing function. Each agent declares what it needs; that defines the layer. That's why it serves products we haven't built yet.</a:t>
+              <a:t>THE key slide. CDP is profile-first; we're job-first. I let the agents' NEEDS be the forcing function — each declares what it needs, that defines the layer. That's why it serves products not built yet.</a:t>
             </a:r>
           </a:p>
         </p:txBody>
@@ -932,7 +932,7 @@
           <a:lstStyle/>
           <a:p>
             <a:r>
-              <a:t>One picture, left to right. Sources are the mess. One — AI maps any schema to canonical events. Two — identity resolution, the keystone. Three — event store is truth, trait store is derived. Four — the Context API; that's what the prototype IS. Then the agents, each a contract. Bottom — the closed loop, where outcomes sharpen the next decision.</a:t>
+              <a:t>Left to right: sources are the mess. One — AI maps any schema to events. Two — identity, the keystone. Three — event store is truth, trait store derived. Four — the Context API, that's the prototype. Then agents, each a contract — including Returns &amp; Refunds, added as just a contract. Bottom — the closed loop.</a:t>
             </a:r>
           </a:p>
         </p:txBody>
@@ -1002,7 +1002,7 @@
           <a:lstStyle/>
           <a:p>
             <a:r>
-              <a:t>Don't rush this — it's the keystone. Three escalating signals, each with a confidence. We tune for precision over recall: a wrong merge is worse than a missed one. Cross-brand is the same graph one level up. Then: two stores on purpose — events are immutable truth, traits are recomputed; a wrong trait, replay and recompute, and contracts never break because agents read traits.</a:t>
+              <a:t>Don't rush it — the keystone. Three escalating signals, each with confidence. Precision over recall: a wrong merge is worse than a missed one. Cross-brand is the same graph one level up. Two stores: events are truth, traits recomputed.</a:t>
             </a:r>
           </a:p>
         </p:txBody>
@@ -1072,7 +1072,7 @@
           <a:lstStyle/>
           <a:p>
             <a:r>
-              <a:t>Criterion two. Five places where AI replaces rules or humans. The prototype shows the last two LIVE — type English, get a segment; minimal context, get a real message. The first three are the same pattern, earlier in the pipeline. If you have a key, run the live generate here.</a:t>
+              <a:t>Criterion two. Five places AI replaces rules or humans. The prototype shows the last two live — English to segment, minimal context to message. If you have a key, run live here.</a:t>
             </a:r>
           </a:p>
         </p:txBody>
@@ -1142,7 +1142,7 @@
           <a:lstStyle/>
           <a:p>
             <a:r>
-              <a:t>The strongest slide — slow down. One brand sees one return; annoying. WE see four of five across three brands; that's a pattern. We pause COD before shipping at a loss. No single brand can build this, and every new brand makes the priors better for everyone. That's the moat — the data layer is the network effect, not a cost center.</a:t>
+              <a:t>Strongest slide — slow down. One brand sees one return; we see four of five across three brands. We pause COD before shipping at a loss. No single brand can build this; every brand makes the priors better. The moat.</a:t>
             </a:r>
           </a:p>
         </p:txBody>
@@ -1212,7 +1212,7 @@
           <a:lstStyle/>
           <a:p>
             <a:r>
-              <a:t>This is how it scales. New product equals a new contract over existing traits. No re-architecture. A new trait, computed once, is available to every future agent. Platform cost stays roughly flat per product — the roadmap speeds up as it grows, instead of bogging down.</a:t>
+              <a:t>How it scales. New product equals a new contract over existing traits. No re-architecture. Returns &amp; Refunds is the proof — I added it as a contract last week. Cost stays flat per product.</a:t>
             </a:r>
           </a:p>
         </p:txBody>
@@ -6015,7 +6015,7 @@
                   <a:srgbClr val="94A3B8"/>
                 </a:solidFill>
               </a:rPr>
-              <a:t>Sources → ① AI schema map → ② identity resolution → ③ event + trait store → ④ Context API → agents → closed loop</a:t>
+              <a:t>Sources → ① AI schema map → ② identity → ③ event + trait store → ④ Context API → agents (incl. Returns &amp; Refunds) → closed loop</a:t>
             </a:r>
           </a:p>
         </p:txBody>

</xml_diff>